<commit_message>
coin flipping P-value - in statistics_05
</commit_message>
<xml_diff>
--- a/statistics_05_normal_p_val.pptx
+++ b/statistics_05_normal_p_val.pptx
@@ -5,15 +5,16 @@
     <p:sldMasterId id="2147483659" r:id="rId1"/>
   </p:sldMasterIdLst>
   <p:notesMasterIdLst>
-    <p:notesMasterId r:id="rId8"/>
+    <p:notesMasterId r:id="rId9"/>
   </p:notesMasterIdLst>
   <p:sldIdLst>
     <p:sldId id="257" r:id="rId2"/>
     <p:sldId id="258" r:id="rId3"/>
     <p:sldId id="259" r:id="rId4"/>
-    <p:sldId id="294" r:id="rId5"/>
-    <p:sldId id="312" r:id="rId6"/>
-    <p:sldId id="310" r:id="rId7"/>
+    <p:sldId id="313" r:id="rId5"/>
+    <p:sldId id="294" r:id="rId6"/>
+    <p:sldId id="312" r:id="rId7"/>
+    <p:sldId id="310" r:id="rId8"/>
   </p:sldIdLst>
   <p:sldSz cx="12192000" cy="6858000"/>
   <p:notesSz cx="6858000" cy="9144000"/>
@@ -1798,6 +1799,115 @@
         </p:spPr>
       </p:sp>
     </p:spTree>
+  </p:cSld>
+  <p:clrMapOvr>
+    <a:masterClrMapping/>
+  </p:clrMapOvr>
+</p:notes>
+</file>
+
+<file path=ppt/notesSlides/notesSlide4.xml><?xml version="1.0" encoding="utf-8"?>
+<p:notes xmlns:a="http://schemas.openxmlformats.org/drawingml/2006/main" xmlns:r="http://schemas.openxmlformats.org/officeDocument/2006/relationships" xmlns:p="http://schemas.openxmlformats.org/presentationml/2006/main" showMasterSp="0" showMasterPhAnim="0">
+  <p:cSld>
+    <p:spTree>
+      <p:nvGrpSpPr>
+        <p:cNvPr id="1" name="Shape 110"/>
+        <p:cNvGrpSpPr/>
+        <p:nvPr/>
+      </p:nvGrpSpPr>
+      <p:grpSpPr>
+        <a:xfrm>
+          <a:off x="0" y="0"/>
+          <a:ext cx="0" cy="0"/>
+          <a:chOff x="0" y="0"/>
+          <a:chExt cx="0" cy="0"/>
+        </a:xfrm>
+      </p:grpSpPr>
+      <p:sp>
+        <p:nvSpPr>
+          <p:cNvPr id="111" name="Google Shape;111;g602e96b36d_0_14:notes"/>
+          <p:cNvSpPr txBox="1">
+            <a:spLocks noGrp="1"/>
+          </p:cNvSpPr>
+          <p:nvPr>
+            <p:ph type="body" idx="1"/>
+          </p:nvPr>
+        </p:nvSpPr>
+        <p:spPr>
+          <a:xfrm>
+            <a:off x="685800" y="4400550"/>
+            <a:ext cx="5486400" cy="3600600"/>
+          </a:xfrm>
+          <a:prstGeom prst="rect">
+            <a:avLst/>
+          </a:prstGeom>
+        </p:spPr>
+        <p:txBody>
+          <a:bodyPr spcFirstLastPara="1" wrap="square" lIns="91425" tIns="91425" rIns="91425" bIns="91425" anchor="t" anchorCtr="0">
+            <a:noAutofit/>
+          </a:bodyPr>
+          <a:lstStyle/>
+          <a:p>
+            <a:pPr marL="0" lvl="0" indent="0" algn="l" rtl="0">
+              <a:spcBef>
+                <a:spcPts val="0"/>
+              </a:spcBef>
+              <a:spcAft>
+                <a:spcPts val="0"/>
+              </a:spcAft>
+              <a:buNone/>
+            </a:pPr>
+            <a:endParaRPr/>
+          </a:p>
+        </p:txBody>
+      </p:sp>
+      <p:sp>
+        <p:nvSpPr>
+          <p:cNvPr id="112" name="Google Shape;112;g602e96b36d_0_14:notes"/>
+          <p:cNvSpPr>
+            <a:spLocks noGrp="1" noRot="1" noChangeAspect="1"/>
+          </p:cNvSpPr>
+          <p:nvPr>
+            <p:ph type="sldImg" idx="2"/>
+          </p:nvPr>
+        </p:nvSpPr>
+        <p:spPr>
+          <a:xfrm>
+            <a:off x="685800" y="1143000"/>
+            <a:ext cx="5486400" cy="3086100"/>
+          </a:xfrm>
+          <a:custGeom>
+            <a:avLst/>
+            <a:gdLst/>
+            <a:ahLst/>
+            <a:cxnLst/>
+            <a:rect l="l" t="t" r="r" b="b"/>
+            <a:pathLst>
+              <a:path w="120000" h="120000" extrusionOk="0">
+                <a:moveTo>
+                  <a:pt x="0" y="0"/>
+                </a:moveTo>
+                <a:lnTo>
+                  <a:pt x="120000" y="0"/>
+                </a:lnTo>
+                <a:lnTo>
+                  <a:pt x="120000" y="120000"/>
+                </a:lnTo>
+                <a:lnTo>
+                  <a:pt x="0" y="120000"/>
+                </a:lnTo>
+                <a:close/>
+              </a:path>
+            </a:pathLst>
+          </a:custGeom>
+        </p:spPr>
+      </p:sp>
+    </p:spTree>
+    <p:extLst>
+      <p:ext uri="{BB962C8B-B14F-4D97-AF65-F5344CB8AC3E}">
+        <p14:creationId xmlns:p14="http://schemas.microsoft.com/office/powerpoint/2010/main" val="3243527872"/>
+      </p:ext>
+    </p:extLst>
   </p:cSld>
   <p:clrMapOvr>
     <a:masterClrMapping/>
@@ -16589,13 +16699,1388 @@
       </p:grpSpPr>
       <p:sp>
         <p:nvSpPr>
+          <p:cNvPr id="4" name="Google Shape;114;p16">
+            <a:extLst>
+              <a:ext uri="{FF2B5EF4-FFF2-40B4-BE49-F238E27FC236}">
+                <a16:creationId xmlns:a16="http://schemas.microsoft.com/office/drawing/2014/main" id="{2852508B-C5FD-2C4A-AFD6-7CEC0F45E3A7}"/>
+              </a:ext>
+            </a:extLst>
+          </p:cNvPr>
+          <p:cNvSpPr txBox="1"/>
+          <p:nvPr/>
+        </p:nvSpPr>
+        <p:spPr>
+          <a:xfrm>
+            <a:off x="1" y="728871"/>
+            <a:ext cx="5367130" cy="3049225"/>
+          </a:xfrm>
+          <a:prstGeom prst="rect">
+            <a:avLst/>
+          </a:prstGeom>
+          <a:noFill/>
+          <a:ln>
+            <a:noFill/>
+          </a:ln>
+        </p:spPr>
+        <p:txBody>
+          <a:bodyPr spcFirstLastPara="1" wrap="square" lIns="91425" tIns="91425" rIns="91425" bIns="91425" anchor="t" anchorCtr="0">
+            <a:noAutofit/>
+          </a:bodyPr>
+          <a:lstStyle/>
+          <a:p>
+            <a:pPr marL="0" lvl="0" indent="0" algn="l" rtl="0">
+              <a:spcBef>
+                <a:spcPts val="0"/>
+              </a:spcBef>
+              <a:spcAft>
+                <a:spcPts val="0"/>
+              </a:spcAft>
+              <a:buNone/>
+            </a:pPr>
+            <a:r>
+              <a:rPr lang="en-US" dirty="0">
+                <a:latin typeface="Calibri"/>
+                <a:ea typeface="Calibri"/>
+                <a:cs typeface="Calibri"/>
+                <a:sym typeface="Calibri"/>
+              </a:rPr>
+              <a:t>Null Hypothesis (H0) :  the coin is fair (flips heads/tails evenly).</a:t>
+            </a:r>
+          </a:p>
+          <a:p>
+            <a:pPr marL="0" lvl="0" indent="0" algn="l" rtl="0">
+              <a:spcBef>
+                <a:spcPts val="0"/>
+              </a:spcBef>
+              <a:spcAft>
+                <a:spcPts val="0"/>
+              </a:spcAft>
+              <a:buNone/>
+            </a:pPr>
+            <a:endParaRPr lang="en-US" dirty="0">
+              <a:latin typeface="Calibri"/>
+              <a:ea typeface="Calibri"/>
+              <a:cs typeface="Calibri"/>
+              <a:sym typeface="Calibri"/>
+            </a:endParaRPr>
+          </a:p>
+          <a:p>
+            <a:pPr marL="0" lvl="0" indent="0" algn="l" rtl="0">
+              <a:spcBef>
+                <a:spcPts val="0"/>
+              </a:spcBef>
+              <a:spcAft>
+                <a:spcPts val="0"/>
+              </a:spcAft>
+              <a:buNone/>
+            </a:pPr>
+            <a:r>
+              <a:rPr lang="en-US" dirty="0">
+                <a:latin typeface="Calibri"/>
+                <a:ea typeface="Calibri"/>
+                <a:cs typeface="Calibri"/>
+                <a:sym typeface="Calibri"/>
+              </a:rPr>
+              <a:t>Alternative (H1): the coin flips heads/tails unevenly with </a:t>
+            </a:r>
+          </a:p>
+          <a:p>
+            <a:pPr marL="0" lvl="0" indent="0" algn="l" rtl="0">
+              <a:spcBef>
+                <a:spcPts val="0"/>
+              </a:spcBef>
+              <a:spcAft>
+                <a:spcPts val="0"/>
+              </a:spcAft>
+              <a:buNone/>
+            </a:pPr>
+            <a:r>
+              <a:rPr lang="en-US" dirty="0">
+                <a:latin typeface="Calibri"/>
+                <a:ea typeface="Calibri"/>
+                <a:cs typeface="Calibri"/>
+                <a:sym typeface="Calibri"/>
+              </a:rPr>
+              <a:t>error </a:t>
+            </a:r>
+            <a:r>
+              <a:rPr lang="en-US" b="1" dirty="0">
+                <a:solidFill>
+                  <a:srgbClr val="0070C0"/>
+                </a:solidFill>
+                <a:latin typeface="Calibri"/>
+                <a:ea typeface="Calibri"/>
+                <a:cs typeface="Calibri"/>
+                <a:sym typeface="Calibri"/>
+              </a:rPr>
+              <a:t>E = |P</a:t>
+            </a:r>
+            <a:r>
+              <a:rPr lang="en-US" b="1" baseline="-25000" dirty="0">
+                <a:solidFill>
+                  <a:srgbClr val="0070C0"/>
+                </a:solidFill>
+                <a:latin typeface="Calibri"/>
+                <a:ea typeface="Calibri"/>
+                <a:cs typeface="Calibri"/>
+                <a:sym typeface="Calibri"/>
+              </a:rPr>
+              <a:t>h</a:t>
+            </a:r>
+            <a:r>
+              <a:rPr lang="en-US" b="1" dirty="0">
+                <a:solidFill>
+                  <a:srgbClr val="0070C0"/>
+                </a:solidFill>
+                <a:latin typeface="Calibri"/>
+                <a:ea typeface="Calibri"/>
+                <a:cs typeface="Calibri"/>
+                <a:sym typeface="Calibri"/>
+              </a:rPr>
+              <a:t>-0.5|</a:t>
+            </a:r>
+            <a:r>
+              <a:rPr lang="en-US" dirty="0">
+                <a:latin typeface="Calibri"/>
+                <a:ea typeface="Calibri"/>
+                <a:cs typeface="Calibri"/>
+                <a:sym typeface="Calibri"/>
+              </a:rPr>
+              <a:t>, where P</a:t>
+            </a:r>
+            <a:r>
+              <a:rPr lang="en-US" baseline="-25000" dirty="0">
+                <a:latin typeface="Calibri"/>
+                <a:ea typeface="Calibri"/>
+                <a:cs typeface="Calibri"/>
+                <a:sym typeface="Calibri"/>
+              </a:rPr>
+              <a:t>h</a:t>
+            </a:r>
+            <a:r>
+              <a:rPr lang="en-US" dirty="0">
+                <a:latin typeface="Calibri"/>
+                <a:ea typeface="Calibri"/>
+                <a:cs typeface="Calibri"/>
+                <a:sym typeface="Calibri"/>
+              </a:rPr>
+              <a:t> is the probability of heads.</a:t>
+            </a:r>
+          </a:p>
+          <a:p>
+            <a:pPr marL="0" lvl="0" indent="0" algn="l" rtl="0">
+              <a:spcBef>
+                <a:spcPts val="0"/>
+              </a:spcBef>
+              <a:spcAft>
+                <a:spcPts val="0"/>
+              </a:spcAft>
+              <a:buNone/>
+            </a:pPr>
+            <a:endParaRPr dirty="0">
+              <a:latin typeface="Calibri"/>
+              <a:ea typeface="Calibri"/>
+              <a:cs typeface="Calibri"/>
+              <a:sym typeface="Calibri"/>
+            </a:endParaRPr>
+          </a:p>
+          <a:p>
+            <a:pPr marL="0" lvl="0" indent="0" algn="l" rtl="0">
+              <a:spcBef>
+                <a:spcPts val="0"/>
+              </a:spcBef>
+              <a:spcAft>
+                <a:spcPts val="0"/>
+              </a:spcAft>
+              <a:buNone/>
+            </a:pPr>
+            <a:r>
+              <a:rPr lang="en-US" sz="1800" b="1" dirty="0">
+                <a:solidFill>
+                  <a:srgbClr val="FF0000"/>
+                </a:solidFill>
+                <a:latin typeface="Calibri"/>
+                <a:ea typeface="Calibri"/>
+                <a:cs typeface="Calibri"/>
+                <a:sym typeface="Calibri"/>
+              </a:rPr>
+              <a:t>Problem 1</a:t>
+            </a:r>
+          </a:p>
+          <a:p>
+            <a:pPr marL="0" lvl="0" indent="0" algn="l" rtl="0">
+              <a:spcBef>
+                <a:spcPts val="0"/>
+              </a:spcBef>
+              <a:spcAft>
+                <a:spcPts val="0"/>
+              </a:spcAft>
+              <a:buNone/>
+            </a:pPr>
+            <a:r>
+              <a:rPr lang="en-US" b="1" dirty="0">
+                <a:solidFill>
+                  <a:srgbClr val="0070C0"/>
+                </a:solidFill>
+                <a:latin typeface="Calibri"/>
+                <a:ea typeface="Calibri"/>
+                <a:cs typeface="Calibri"/>
+                <a:sym typeface="Calibri"/>
+              </a:rPr>
+              <a:t>We tossed a coin 10 times and got 8 heads. Compute p-value.</a:t>
+            </a:r>
+          </a:p>
+          <a:p>
+            <a:pPr lvl="0"/>
+            <a:endParaRPr lang="en-US" dirty="0">
+              <a:latin typeface="Calibri"/>
+              <a:ea typeface="Calibri"/>
+              <a:cs typeface="Calibri"/>
+              <a:sym typeface="Calibri"/>
+            </a:endParaRPr>
+          </a:p>
+          <a:p>
+            <a:pPr lvl="0"/>
+            <a:r>
+              <a:rPr lang="en-US" dirty="0">
+                <a:latin typeface="Calibri"/>
+                <a:ea typeface="Calibri"/>
+                <a:cs typeface="Calibri"/>
+                <a:sym typeface="Calibri"/>
+              </a:rPr>
+              <a:t>We just need compute the probability of 8 or more heads in 10 tosses (assuming the coin is fair).</a:t>
+            </a:r>
+          </a:p>
+          <a:p>
+            <a:pPr lvl="0"/>
+            <a:r>
+              <a:rPr lang="en-US" dirty="0">
+                <a:latin typeface="Calibri"/>
+                <a:ea typeface="Calibri"/>
+                <a:cs typeface="Calibri"/>
+                <a:sym typeface="Calibri"/>
+              </a:rPr>
+              <a:t>Note that the number of heads follows a binomial distribution </a:t>
+            </a:r>
+          </a:p>
+          <a:p>
+            <a:pPr lvl="0"/>
+            <a:r>
+              <a:rPr lang="en-US" dirty="0">
+                <a:latin typeface="Calibri"/>
+                <a:ea typeface="Calibri"/>
+                <a:cs typeface="Calibri"/>
+                <a:sym typeface="Calibri"/>
+              </a:rPr>
+              <a:t>with n=10 and p=0.5.</a:t>
+            </a:r>
+          </a:p>
+          <a:p>
+            <a:pPr lvl="0"/>
+            <a:r>
+              <a:rPr lang="en-US" dirty="0">
+                <a:latin typeface="Calibri"/>
+                <a:ea typeface="Calibri"/>
+                <a:cs typeface="Calibri"/>
+                <a:sym typeface="Calibri"/>
+              </a:rPr>
+              <a:t>So the p-value = P[8] + P[9] + P[10] = .044 + .01 + .001 = 0.055.</a:t>
+            </a:r>
+          </a:p>
+          <a:p>
+            <a:pPr lvl="0"/>
+            <a:endParaRPr lang="en-US" dirty="0">
+              <a:latin typeface="Calibri"/>
+              <a:ea typeface="Calibri"/>
+              <a:cs typeface="Calibri"/>
+              <a:sym typeface="Calibri"/>
+            </a:endParaRPr>
+          </a:p>
+          <a:p>
+            <a:pPr lvl="0"/>
+            <a:endParaRPr lang="en-US" dirty="0">
+              <a:latin typeface="Calibri"/>
+              <a:ea typeface="Calibri"/>
+              <a:cs typeface="Calibri"/>
+              <a:sym typeface="Calibri"/>
+            </a:endParaRPr>
+          </a:p>
+          <a:p>
+            <a:pPr lvl="0"/>
+            <a:endParaRPr lang="en-US" dirty="0">
+              <a:latin typeface="Calibri"/>
+              <a:ea typeface="Calibri"/>
+              <a:cs typeface="Calibri"/>
+              <a:sym typeface="Calibri"/>
+            </a:endParaRPr>
+          </a:p>
+          <a:p>
+            <a:pPr lvl="0"/>
+            <a:endParaRPr lang="en-US" dirty="0">
+              <a:latin typeface="Calibri"/>
+              <a:ea typeface="Calibri"/>
+              <a:cs typeface="Calibri"/>
+              <a:sym typeface="Calibri"/>
+            </a:endParaRPr>
+          </a:p>
+          <a:p>
+            <a:pPr lvl="0"/>
+            <a:endParaRPr lang="en-US" dirty="0">
+              <a:latin typeface="Calibri"/>
+              <a:ea typeface="Calibri"/>
+              <a:cs typeface="Calibri"/>
+              <a:sym typeface="Calibri"/>
+            </a:endParaRPr>
+          </a:p>
+          <a:p>
+            <a:pPr lvl="0"/>
+            <a:endParaRPr lang="en-US" dirty="0">
+              <a:latin typeface="Calibri"/>
+              <a:ea typeface="Calibri"/>
+              <a:cs typeface="Calibri"/>
+              <a:sym typeface="Calibri"/>
+            </a:endParaRPr>
+          </a:p>
+        </p:txBody>
+      </p:sp>
+      <p:sp>
+        <p:nvSpPr>
+          <p:cNvPr id="5" name="Google Shape;114;p16">
+            <a:extLst>
+              <a:ext uri="{FF2B5EF4-FFF2-40B4-BE49-F238E27FC236}">
+                <a16:creationId xmlns:a16="http://schemas.microsoft.com/office/drawing/2014/main" id="{1A2BC264-BF2C-904D-AAF6-592DE154D8FE}"/>
+              </a:ext>
+            </a:extLst>
+          </p:cNvPr>
+          <p:cNvSpPr txBox="1"/>
+          <p:nvPr/>
+        </p:nvSpPr>
+        <p:spPr>
+          <a:xfrm>
+            <a:off x="0" y="0"/>
+            <a:ext cx="6056582" cy="848139"/>
+          </a:xfrm>
+          <a:prstGeom prst="rect">
+            <a:avLst/>
+          </a:prstGeom>
+          <a:noFill/>
+          <a:ln>
+            <a:noFill/>
+          </a:ln>
+        </p:spPr>
+        <p:txBody>
+          <a:bodyPr spcFirstLastPara="1" wrap="square" lIns="91425" tIns="91425" rIns="91425" bIns="91425" anchor="t" anchorCtr="0">
+            <a:noAutofit/>
+          </a:bodyPr>
+          <a:lstStyle/>
+          <a:p>
+            <a:pPr marL="0" lvl="0" indent="0" algn="l" rtl="0">
+              <a:spcBef>
+                <a:spcPts val="0"/>
+              </a:spcBef>
+              <a:spcAft>
+                <a:spcPts val="0"/>
+              </a:spcAft>
+              <a:buNone/>
+            </a:pPr>
+            <a:r>
+              <a:rPr lang="en-US" sz="2400" b="1" dirty="0">
+                <a:latin typeface="Calibri"/>
+                <a:ea typeface="Calibri"/>
+                <a:cs typeface="Calibri"/>
+                <a:sym typeface="Calibri"/>
+              </a:rPr>
+              <a:t>Checking whether a coin is fair</a:t>
+            </a:r>
+            <a:endParaRPr sz="2400" b="1" dirty="0">
+              <a:latin typeface="Calibri"/>
+              <a:ea typeface="Calibri"/>
+              <a:cs typeface="Calibri"/>
+              <a:sym typeface="Calibri"/>
+            </a:endParaRPr>
+          </a:p>
+          <a:p>
+            <a:pPr marL="0" lvl="0" indent="0" algn="l" rtl="0">
+              <a:spcBef>
+                <a:spcPts val="0"/>
+              </a:spcBef>
+              <a:spcAft>
+                <a:spcPts val="0"/>
+              </a:spcAft>
+              <a:buNone/>
+            </a:pPr>
+            <a:endParaRPr sz="800" dirty="0">
+              <a:latin typeface="Calibri"/>
+              <a:ea typeface="Calibri"/>
+              <a:cs typeface="Calibri"/>
+              <a:sym typeface="Calibri"/>
+            </a:endParaRPr>
+          </a:p>
+          <a:p>
+            <a:pPr lvl="0"/>
+            <a:r>
+              <a:rPr lang="en-US" dirty="0">
+                <a:latin typeface="Calibri"/>
+                <a:ea typeface="Calibri"/>
+                <a:cs typeface="Calibri"/>
+                <a:sym typeface="Calibri"/>
+                <a:hlinkClick r:id="rId3"/>
+              </a:rPr>
+              <a:t>https://en.wikipedia.org/wiki/Checking_whether_a_coin_is_fair</a:t>
+            </a:r>
+            <a:r>
+              <a:rPr lang="en-US" dirty="0">
+                <a:latin typeface="Calibri"/>
+                <a:ea typeface="Calibri"/>
+                <a:cs typeface="Calibri"/>
+                <a:sym typeface="Calibri"/>
+              </a:rPr>
+              <a:t> </a:t>
+            </a:r>
+          </a:p>
+        </p:txBody>
+      </p:sp>
+      <p:pic>
+        <p:nvPicPr>
+          <p:cNvPr id="2" name="Picture 1">
+            <a:extLst>
+              <a:ext uri="{FF2B5EF4-FFF2-40B4-BE49-F238E27FC236}">
+                <a16:creationId xmlns:a16="http://schemas.microsoft.com/office/drawing/2014/main" id="{9C3F7295-12F5-4F43-9EB1-ECBFAD4AE198}"/>
+              </a:ext>
+            </a:extLst>
+          </p:cNvPr>
+          <p:cNvPicPr>
+            <a:picLocks noChangeAspect="1"/>
+          </p:cNvPicPr>
+          <p:nvPr/>
+        </p:nvPicPr>
+        <p:blipFill>
+          <a:blip r:embed="rId4"/>
+          <a:stretch>
+            <a:fillRect/>
+          </a:stretch>
+        </p:blipFill>
+        <p:spPr>
+          <a:xfrm>
+            <a:off x="10670547" y="3041496"/>
+            <a:ext cx="711200" cy="736600"/>
+          </a:xfrm>
+          <a:prstGeom prst="rect">
+            <a:avLst/>
+          </a:prstGeom>
+        </p:spPr>
+      </p:pic>
+      <p:pic>
+        <p:nvPicPr>
+          <p:cNvPr id="7" name="Picture 6">
+            <a:extLst>
+              <a:ext uri="{FF2B5EF4-FFF2-40B4-BE49-F238E27FC236}">
+                <a16:creationId xmlns:a16="http://schemas.microsoft.com/office/drawing/2014/main" id="{A7C773EC-98DC-EB45-9CD6-4ACB52A409DE}"/>
+              </a:ext>
+            </a:extLst>
+          </p:cNvPr>
+          <p:cNvPicPr>
+            <a:picLocks noChangeAspect="1"/>
+          </p:cNvPicPr>
+          <p:nvPr/>
+        </p:nvPicPr>
+        <p:blipFill>
+          <a:blip r:embed="rId5" cstate="email">
+            <a:extLst>
+              <a:ext uri="{28A0092B-C50C-407E-A947-70E740481C1C}">
+                <a14:useLocalDpi xmlns:a14="http://schemas.microsoft.com/office/drawing/2010/main"/>
+              </a:ext>
+            </a:extLst>
+          </a:blip>
+          <a:stretch>
+            <a:fillRect/>
+          </a:stretch>
+        </p:blipFill>
+        <p:spPr>
+          <a:xfrm>
+            <a:off x="6950767" y="1868560"/>
+            <a:ext cx="5039256" cy="772060"/>
+          </a:xfrm>
+          <a:prstGeom prst="rect">
+            <a:avLst/>
+          </a:prstGeom>
+        </p:spPr>
+      </p:pic>
+      <p:sp>
+        <p:nvSpPr>
+          <p:cNvPr id="8" name="Google Shape;114;p16">
+            <a:extLst>
+              <a:ext uri="{FF2B5EF4-FFF2-40B4-BE49-F238E27FC236}">
+                <a16:creationId xmlns:a16="http://schemas.microsoft.com/office/drawing/2014/main" id="{3ABF9FFE-6500-4147-9C1B-BC0CFD06A921}"/>
+              </a:ext>
+            </a:extLst>
+          </p:cNvPr>
+          <p:cNvSpPr txBox="1"/>
+          <p:nvPr/>
+        </p:nvSpPr>
+        <p:spPr>
+          <a:xfrm>
+            <a:off x="6685723" y="205411"/>
+            <a:ext cx="5367130" cy="1928189"/>
+          </a:xfrm>
+          <a:prstGeom prst="rect">
+            <a:avLst/>
+          </a:prstGeom>
+          <a:noFill/>
+          <a:ln>
+            <a:noFill/>
+          </a:ln>
+        </p:spPr>
+        <p:txBody>
+          <a:bodyPr spcFirstLastPara="1" wrap="square" lIns="91425" tIns="91425" rIns="91425" bIns="91425" anchor="t" anchorCtr="0">
+            <a:noAutofit/>
+          </a:bodyPr>
+          <a:lstStyle/>
+          <a:p>
+            <a:pPr lvl="0"/>
+            <a:r>
+              <a:rPr lang="en-US" sz="1800" b="1" dirty="0">
+                <a:solidFill>
+                  <a:srgbClr val="FF0000"/>
+                </a:solidFill>
+                <a:latin typeface="Calibri"/>
+                <a:cs typeface="Calibri"/>
+                <a:sym typeface="Calibri"/>
+              </a:rPr>
+              <a:t>Problem 2</a:t>
+            </a:r>
+          </a:p>
+          <a:p>
+            <a:pPr lvl="0"/>
+            <a:r>
+              <a:rPr lang="en-US" b="1" dirty="0">
+                <a:solidFill>
+                  <a:srgbClr val="0070C0"/>
+                </a:solidFill>
+                <a:latin typeface="Calibri"/>
+                <a:ea typeface="Calibri"/>
+                <a:cs typeface="Calibri"/>
+                <a:sym typeface="Calibri"/>
+              </a:rPr>
+              <a:t>How many times should we flip a coin to test the null hypothesis.</a:t>
+            </a:r>
+          </a:p>
+          <a:p>
+            <a:pPr lvl="0"/>
+            <a:endParaRPr lang="en-US" dirty="0">
+              <a:latin typeface="Calibri"/>
+              <a:ea typeface="Calibri"/>
+              <a:cs typeface="Calibri"/>
+              <a:sym typeface="Calibri"/>
+            </a:endParaRPr>
+          </a:p>
+          <a:p>
+            <a:pPr lvl="0"/>
+            <a:r>
+              <a:rPr lang="en-US" dirty="0">
+                <a:latin typeface="Calibri"/>
+                <a:ea typeface="Calibri"/>
+                <a:cs typeface="Calibri"/>
+                <a:sym typeface="Calibri"/>
+              </a:rPr>
+              <a:t>Suppose we flipped "n" times and got "x" heads.</a:t>
+            </a:r>
+          </a:p>
+          <a:p>
+            <a:pPr lvl="0"/>
+            <a:r>
+              <a:rPr lang="en-US" dirty="0">
+                <a:latin typeface="Calibri"/>
+                <a:ea typeface="Calibri"/>
+                <a:cs typeface="Calibri"/>
+                <a:sym typeface="Calibri"/>
+              </a:rPr>
+              <a:t>The estimate of the probability of heads P</a:t>
+            </a:r>
+            <a:r>
+              <a:rPr lang="en-US" baseline="-25000" dirty="0">
+                <a:latin typeface="Calibri"/>
+                <a:ea typeface="Calibri"/>
+                <a:cs typeface="Calibri"/>
+                <a:sym typeface="Calibri"/>
+              </a:rPr>
+              <a:t>h</a:t>
+            </a:r>
+            <a:r>
+              <a:rPr lang="en-US" dirty="0">
+                <a:latin typeface="Calibri"/>
+                <a:ea typeface="Calibri"/>
+                <a:cs typeface="Calibri"/>
+                <a:sym typeface="Calibri"/>
+              </a:rPr>
+              <a:t> = x/n.</a:t>
+            </a:r>
+          </a:p>
+          <a:p>
+            <a:pPr lvl="0"/>
+            <a:r>
+              <a:rPr lang="en-US" dirty="0">
+                <a:latin typeface="Calibri"/>
+                <a:ea typeface="Calibri"/>
+                <a:cs typeface="Calibri"/>
+                <a:sym typeface="Calibri"/>
+              </a:rPr>
+              <a:t>Suppose "x" follows binomial distribution with probability "p" of heads.</a:t>
+            </a:r>
+          </a:p>
+          <a:p>
+            <a:pPr lvl="0"/>
+            <a:r>
+              <a:rPr lang="en-US" dirty="0">
+                <a:latin typeface="Calibri"/>
+                <a:ea typeface="Calibri"/>
+                <a:cs typeface="Calibri"/>
+                <a:sym typeface="Calibri"/>
+              </a:rPr>
+              <a:t>At large "n" is is approximated with normal distribution.</a:t>
+            </a:r>
+          </a:p>
+          <a:p>
+            <a:pPr lvl="0"/>
+            <a:endParaRPr lang="en-US" dirty="0">
+              <a:latin typeface="Calibri"/>
+              <a:ea typeface="Calibri"/>
+              <a:cs typeface="Calibri"/>
+              <a:sym typeface="Calibri"/>
+            </a:endParaRPr>
+          </a:p>
+          <a:p>
+            <a:pPr lvl="0"/>
+            <a:endParaRPr lang="en-US" dirty="0">
+              <a:latin typeface="Calibri"/>
+              <a:ea typeface="Calibri"/>
+              <a:cs typeface="Calibri"/>
+              <a:sym typeface="Calibri"/>
+            </a:endParaRPr>
+          </a:p>
+          <a:p>
+            <a:pPr lvl="0"/>
+            <a:endParaRPr lang="en-US" dirty="0">
+              <a:latin typeface="Calibri"/>
+              <a:ea typeface="Calibri"/>
+              <a:cs typeface="Calibri"/>
+              <a:sym typeface="Calibri"/>
+            </a:endParaRPr>
+          </a:p>
+        </p:txBody>
+      </p:sp>
+      <p:sp>
+        <p:nvSpPr>
+          <p:cNvPr id="9" name="Google Shape;114;p16">
+            <a:extLst>
+              <a:ext uri="{FF2B5EF4-FFF2-40B4-BE49-F238E27FC236}">
+                <a16:creationId xmlns:a16="http://schemas.microsoft.com/office/drawing/2014/main" id="{38871C2A-D7DF-804C-B877-B6E6E95240DB}"/>
+              </a:ext>
+            </a:extLst>
+          </p:cNvPr>
+          <p:cNvSpPr txBox="1"/>
+          <p:nvPr/>
+        </p:nvSpPr>
+        <p:spPr>
+          <a:xfrm>
+            <a:off x="6685723" y="2640620"/>
+            <a:ext cx="5367130" cy="801753"/>
+          </a:xfrm>
+          <a:prstGeom prst="rect">
+            <a:avLst/>
+          </a:prstGeom>
+          <a:noFill/>
+          <a:ln>
+            <a:noFill/>
+          </a:ln>
+        </p:spPr>
+        <p:txBody>
+          <a:bodyPr spcFirstLastPara="1" wrap="square" lIns="91425" tIns="91425" rIns="91425" bIns="91425" anchor="t" anchorCtr="0">
+            <a:noAutofit/>
+          </a:bodyPr>
+          <a:lstStyle/>
+          <a:p>
+            <a:pPr lvl="0"/>
+            <a:r>
+              <a:rPr lang="en-US" dirty="0">
+                <a:latin typeface="Calibri"/>
+                <a:ea typeface="Calibri"/>
+                <a:cs typeface="Calibri"/>
+                <a:sym typeface="Calibri"/>
+              </a:rPr>
+              <a:t>So the standard error of estimating x will be sqrt(np(1-p)).</a:t>
+            </a:r>
+          </a:p>
+          <a:p>
+            <a:pPr lvl="0"/>
+            <a:r>
+              <a:rPr lang="en-US" dirty="0">
+                <a:latin typeface="Calibri"/>
+                <a:ea typeface="Calibri"/>
+                <a:cs typeface="Calibri"/>
+                <a:sym typeface="Calibri"/>
+              </a:rPr>
+              <a:t>Note that it has max value when p=0.5.</a:t>
+            </a:r>
+          </a:p>
+          <a:p>
+            <a:pPr lvl="0"/>
+            <a:r>
+              <a:rPr lang="en-US" dirty="0">
+                <a:latin typeface="Calibri"/>
+                <a:ea typeface="Calibri"/>
+                <a:cs typeface="Calibri"/>
+                <a:sym typeface="Calibri"/>
+              </a:rPr>
+              <a:t>So lets use the upper estimate of error of (x/n) as:</a:t>
+            </a:r>
+          </a:p>
+          <a:p>
+            <a:pPr lvl="0"/>
+            <a:endParaRPr lang="en-US" dirty="0">
+              <a:latin typeface="Calibri"/>
+              <a:ea typeface="Calibri"/>
+              <a:cs typeface="Calibri"/>
+              <a:sym typeface="Calibri"/>
+            </a:endParaRPr>
+          </a:p>
+          <a:p>
+            <a:pPr lvl="0"/>
+            <a:endParaRPr lang="en-US" dirty="0">
+              <a:latin typeface="Calibri"/>
+              <a:ea typeface="Calibri"/>
+              <a:cs typeface="Calibri"/>
+              <a:sym typeface="Calibri"/>
+            </a:endParaRPr>
+          </a:p>
+          <a:p>
+            <a:pPr lvl="0"/>
+            <a:endParaRPr lang="en-US" dirty="0">
+              <a:latin typeface="Calibri"/>
+              <a:ea typeface="Calibri"/>
+              <a:cs typeface="Calibri"/>
+              <a:sym typeface="Calibri"/>
+            </a:endParaRPr>
+          </a:p>
+          <a:p>
+            <a:pPr lvl="0"/>
+            <a:endParaRPr lang="en-US" dirty="0">
+              <a:latin typeface="Calibri"/>
+              <a:ea typeface="Calibri"/>
+              <a:cs typeface="Calibri"/>
+              <a:sym typeface="Calibri"/>
+            </a:endParaRPr>
+          </a:p>
+          <a:p>
+            <a:pPr lvl="0"/>
+            <a:endParaRPr lang="en-US" dirty="0">
+              <a:latin typeface="Calibri"/>
+              <a:ea typeface="Calibri"/>
+              <a:cs typeface="Calibri"/>
+              <a:sym typeface="Calibri"/>
+            </a:endParaRPr>
+          </a:p>
+          <a:p>
+            <a:pPr lvl="0"/>
+            <a:endParaRPr lang="en-US" dirty="0">
+              <a:latin typeface="Calibri"/>
+              <a:ea typeface="Calibri"/>
+              <a:cs typeface="Calibri"/>
+              <a:sym typeface="Calibri"/>
+            </a:endParaRPr>
+          </a:p>
+          <a:p>
+            <a:pPr lvl="0"/>
+            <a:endParaRPr lang="en-US" dirty="0">
+              <a:latin typeface="Calibri"/>
+              <a:ea typeface="Calibri"/>
+              <a:cs typeface="Calibri"/>
+              <a:sym typeface="Calibri"/>
+            </a:endParaRPr>
+          </a:p>
+        </p:txBody>
+      </p:sp>
+      <p:sp>
+        <p:nvSpPr>
+          <p:cNvPr id="3" name="TextBox 2">
+            <a:extLst>
+              <a:ext uri="{FF2B5EF4-FFF2-40B4-BE49-F238E27FC236}">
+                <a16:creationId xmlns:a16="http://schemas.microsoft.com/office/drawing/2014/main" id="{75B5C5ED-1366-1245-9C4A-37065BB20DC4}"/>
+              </a:ext>
+            </a:extLst>
+          </p:cNvPr>
+          <p:cNvSpPr txBox="1"/>
+          <p:nvPr/>
+        </p:nvSpPr>
+        <p:spPr>
+          <a:xfrm>
+            <a:off x="298343" y="4555555"/>
+            <a:ext cx="3491779" cy="2123658"/>
+          </a:xfrm>
+          <a:prstGeom prst="rect">
+            <a:avLst/>
+          </a:prstGeom>
+          <a:noFill/>
+        </p:spPr>
+        <p:txBody>
+          <a:bodyPr wrap="square" rtlCol="0">
+            <a:spAutoFit/>
+          </a:bodyPr>
+          <a:lstStyle/>
+          <a:p>
+            <a:r>
+              <a:rPr lang="en-US" sz="1100" dirty="0">
+                <a:solidFill>
+                  <a:srgbClr val="0070C0"/>
+                </a:solidFill>
+                <a:latin typeface="Consolas" panose="020B0609020204030204" pitchFamily="49" charset="0"/>
+                <a:cs typeface="Consolas" panose="020B0609020204030204" pitchFamily="49" charset="0"/>
+              </a:rPr>
+              <a:t>Z value | Confidence level | Comment     </a:t>
+            </a:r>
+          </a:p>
+          <a:p>
+            <a:r>
+              <a:rPr lang="en-US" sz="1100" dirty="0">
+                <a:solidFill>
+                  <a:srgbClr val="0070C0"/>
+                </a:solidFill>
+                <a:latin typeface="Consolas" panose="020B0609020204030204" pitchFamily="49" charset="0"/>
+                <a:cs typeface="Consolas" panose="020B0609020204030204" pitchFamily="49" charset="0"/>
+              </a:rPr>
+              <a:t>0.6745  |  50.000%         | Half        </a:t>
+            </a:r>
+          </a:p>
+          <a:p>
+            <a:r>
+              <a:rPr lang="en-US" sz="1100" dirty="0">
+                <a:solidFill>
+                  <a:srgbClr val="0070C0"/>
+                </a:solidFill>
+                <a:latin typeface="Consolas" panose="020B0609020204030204" pitchFamily="49" charset="0"/>
+                <a:cs typeface="Consolas" panose="020B0609020204030204" pitchFamily="49" charset="0"/>
+              </a:rPr>
+              <a:t>1.0000  |  68.269%         | One </a:t>
+            </a:r>
+            <a:r>
+              <a:rPr lang="en-US" sz="1100" dirty="0" err="1">
+                <a:solidFill>
+                  <a:srgbClr val="0070C0"/>
+                </a:solidFill>
+                <a:latin typeface="Consolas" panose="020B0609020204030204" pitchFamily="49" charset="0"/>
+                <a:cs typeface="Consolas" panose="020B0609020204030204" pitchFamily="49" charset="0"/>
+              </a:rPr>
+              <a:t>std</a:t>
+            </a:r>
+            <a:r>
+              <a:rPr lang="en-US" sz="1100" dirty="0">
+                <a:solidFill>
+                  <a:srgbClr val="0070C0"/>
+                </a:solidFill>
+                <a:latin typeface="Consolas" panose="020B0609020204030204" pitchFamily="49" charset="0"/>
+                <a:cs typeface="Consolas" panose="020B0609020204030204" pitchFamily="49" charset="0"/>
+              </a:rPr>
+              <a:t> dev </a:t>
+            </a:r>
+          </a:p>
+          <a:p>
+            <a:r>
+              <a:rPr lang="en-US" sz="1100" dirty="0">
+                <a:solidFill>
+                  <a:srgbClr val="0070C0"/>
+                </a:solidFill>
+                <a:latin typeface="Consolas" panose="020B0609020204030204" pitchFamily="49" charset="0"/>
+                <a:cs typeface="Consolas" panose="020B0609020204030204" pitchFamily="49" charset="0"/>
+              </a:rPr>
+              <a:t>1.6449  |  90.000%         | "One nine"  </a:t>
+            </a:r>
+          </a:p>
+          <a:p>
+            <a:r>
+              <a:rPr lang="en-US" sz="1100" dirty="0">
+                <a:solidFill>
+                  <a:srgbClr val="0070C0"/>
+                </a:solidFill>
+                <a:latin typeface="Consolas" panose="020B0609020204030204" pitchFamily="49" charset="0"/>
+                <a:cs typeface="Consolas" panose="020B0609020204030204" pitchFamily="49" charset="0"/>
+              </a:rPr>
+              <a:t>1.9599  |  95.000%         | 95 percent  </a:t>
+            </a:r>
+          </a:p>
+          <a:p>
+            <a:r>
+              <a:rPr lang="en-US" sz="1100" dirty="0">
+                <a:solidFill>
+                  <a:srgbClr val="0070C0"/>
+                </a:solidFill>
+                <a:latin typeface="Consolas" panose="020B0609020204030204" pitchFamily="49" charset="0"/>
+                <a:cs typeface="Consolas" panose="020B0609020204030204" pitchFamily="49" charset="0"/>
+              </a:rPr>
+              <a:t>2.0000  |  95.450%         | Two </a:t>
+            </a:r>
+            <a:r>
+              <a:rPr lang="en-US" sz="1100" dirty="0" err="1">
+                <a:solidFill>
+                  <a:srgbClr val="0070C0"/>
+                </a:solidFill>
+                <a:latin typeface="Consolas" panose="020B0609020204030204" pitchFamily="49" charset="0"/>
+                <a:cs typeface="Consolas" panose="020B0609020204030204" pitchFamily="49" charset="0"/>
+              </a:rPr>
+              <a:t>std</a:t>
+            </a:r>
+            <a:r>
+              <a:rPr lang="en-US" sz="1100" dirty="0">
+                <a:solidFill>
+                  <a:srgbClr val="0070C0"/>
+                </a:solidFill>
+                <a:latin typeface="Consolas" panose="020B0609020204030204" pitchFamily="49" charset="0"/>
+                <a:cs typeface="Consolas" panose="020B0609020204030204" pitchFamily="49" charset="0"/>
+              </a:rPr>
+              <a:t> dev </a:t>
+            </a:r>
+          </a:p>
+          <a:p>
+            <a:r>
+              <a:rPr lang="en-US" sz="1100" dirty="0">
+                <a:solidFill>
+                  <a:srgbClr val="0070C0"/>
+                </a:solidFill>
+                <a:latin typeface="Consolas" panose="020B0609020204030204" pitchFamily="49" charset="0"/>
+                <a:cs typeface="Consolas" panose="020B0609020204030204" pitchFamily="49" charset="0"/>
+              </a:rPr>
+              <a:t>2.5759  |  99.000%         | "Two nines" </a:t>
+            </a:r>
+          </a:p>
+          <a:p>
+            <a:r>
+              <a:rPr lang="en-US" sz="1100" dirty="0">
+                <a:solidFill>
+                  <a:srgbClr val="0070C0"/>
+                </a:solidFill>
+                <a:latin typeface="Consolas" panose="020B0609020204030204" pitchFamily="49" charset="0"/>
+                <a:cs typeface="Consolas" panose="020B0609020204030204" pitchFamily="49" charset="0"/>
+              </a:rPr>
+              <a:t>3.0000  |  99.730%         | Three </a:t>
+            </a:r>
+            <a:r>
+              <a:rPr lang="en-US" sz="1100" dirty="0" err="1">
+                <a:solidFill>
+                  <a:srgbClr val="0070C0"/>
+                </a:solidFill>
+                <a:latin typeface="Consolas" panose="020B0609020204030204" pitchFamily="49" charset="0"/>
+                <a:cs typeface="Consolas" panose="020B0609020204030204" pitchFamily="49" charset="0"/>
+              </a:rPr>
+              <a:t>std</a:t>
+            </a:r>
+            <a:r>
+              <a:rPr lang="en-US" sz="1100" dirty="0">
+                <a:solidFill>
+                  <a:srgbClr val="0070C0"/>
+                </a:solidFill>
+                <a:latin typeface="Consolas" panose="020B0609020204030204" pitchFamily="49" charset="0"/>
+                <a:cs typeface="Consolas" panose="020B0609020204030204" pitchFamily="49" charset="0"/>
+              </a:rPr>
+              <a:t> dev</a:t>
+            </a:r>
+          </a:p>
+          <a:p>
+            <a:r>
+              <a:rPr lang="en-US" sz="1100" dirty="0">
+                <a:solidFill>
+                  <a:srgbClr val="0070C0"/>
+                </a:solidFill>
+                <a:latin typeface="Consolas" panose="020B0609020204030204" pitchFamily="49" charset="0"/>
+                <a:cs typeface="Consolas" panose="020B0609020204030204" pitchFamily="49" charset="0"/>
+              </a:rPr>
+              <a:t>3.2905  |  99.900%         | "Three nines</a:t>
+            </a:r>
+          </a:p>
+          <a:p>
+            <a:r>
+              <a:rPr lang="en-US" sz="1100" dirty="0">
+                <a:solidFill>
+                  <a:srgbClr val="0070C0"/>
+                </a:solidFill>
+                <a:latin typeface="Consolas" panose="020B0609020204030204" pitchFamily="49" charset="0"/>
+                <a:cs typeface="Consolas" panose="020B0609020204030204" pitchFamily="49" charset="0"/>
+              </a:rPr>
+              <a:t>3.8906  |  99.990%         | "Four nines"</a:t>
+            </a:r>
+          </a:p>
+          <a:p>
+            <a:r>
+              <a:rPr lang="en-US" sz="1100" dirty="0">
+                <a:solidFill>
+                  <a:srgbClr val="0070C0"/>
+                </a:solidFill>
+                <a:latin typeface="Consolas" panose="020B0609020204030204" pitchFamily="49" charset="0"/>
+                <a:cs typeface="Consolas" panose="020B0609020204030204" pitchFamily="49" charset="0"/>
+              </a:rPr>
+              <a:t>4.0000  |  99.993%         | Four </a:t>
+            </a:r>
+            <a:r>
+              <a:rPr lang="en-US" sz="1100" dirty="0" err="1">
+                <a:solidFill>
+                  <a:srgbClr val="0070C0"/>
+                </a:solidFill>
+                <a:latin typeface="Consolas" panose="020B0609020204030204" pitchFamily="49" charset="0"/>
+                <a:cs typeface="Consolas" panose="020B0609020204030204" pitchFamily="49" charset="0"/>
+              </a:rPr>
+              <a:t>std</a:t>
+            </a:r>
+            <a:r>
+              <a:rPr lang="en-US" sz="1100" dirty="0">
+                <a:solidFill>
+                  <a:srgbClr val="0070C0"/>
+                </a:solidFill>
+                <a:latin typeface="Consolas" panose="020B0609020204030204" pitchFamily="49" charset="0"/>
+                <a:cs typeface="Consolas" panose="020B0609020204030204" pitchFamily="49" charset="0"/>
+              </a:rPr>
+              <a:t> dev</a:t>
+            </a:r>
+          </a:p>
+          <a:p>
+            <a:r>
+              <a:rPr lang="en-US" sz="1100" dirty="0">
+                <a:solidFill>
+                  <a:srgbClr val="0070C0"/>
+                </a:solidFill>
+                <a:latin typeface="Consolas" panose="020B0609020204030204" pitchFamily="49" charset="0"/>
+                <a:cs typeface="Consolas" panose="020B0609020204030204" pitchFamily="49" charset="0"/>
+              </a:rPr>
+              <a:t>4.4172  |  99.999%         | "Five nines"</a:t>
+            </a:r>
+          </a:p>
+        </p:txBody>
+      </p:sp>
+      <p:sp>
+        <p:nvSpPr>
+          <p:cNvPr id="6" name="TextBox 5">
+            <a:extLst>
+              <a:ext uri="{FF2B5EF4-FFF2-40B4-BE49-F238E27FC236}">
+                <a16:creationId xmlns:a16="http://schemas.microsoft.com/office/drawing/2014/main" id="{A678E832-6A66-A34B-8638-25385B81C915}"/>
+              </a:ext>
+            </a:extLst>
+          </p:cNvPr>
+          <p:cNvSpPr txBox="1"/>
+          <p:nvPr/>
+        </p:nvSpPr>
+        <p:spPr>
+          <a:xfrm>
+            <a:off x="1" y="3897364"/>
+            <a:ext cx="4108174" cy="600164"/>
+          </a:xfrm>
+          <a:prstGeom prst="rect">
+            <a:avLst/>
+          </a:prstGeom>
+          <a:noFill/>
+        </p:spPr>
+        <p:txBody>
+          <a:bodyPr wrap="square" rtlCol="0">
+            <a:spAutoFit/>
+          </a:bodyPr>
+          <a:lstStyle/>
+          <a:p>
+            <a:r>
+              <a:rPr lang="en-US" sz="1100" dirty="0">
+                <a:solidFill>
+                  <a:srgbClr val="0070C0"/>
+                </a:solidFill>
+              </a:rPr>
+              <a:t>Coin flipping leads to binomial distribution, </a:t>
+            </a:r>
+          </a:p>
+          <a:p>
+            <a:r>
+              <a:rPr lang="en-US" sz="1100" dirty="0">
+                <a:solidFill>
+                  <a:srgbClr val="0070C0"/>
+                </a:solidFill>
+              </a:rPr>
+              <a:t>which can be approximated with normal Gaussian distribution.</a:t>
+            </a:r>
+          </a:p>
+          <a:p>
+            <a:r>
+              <a:rPr lang="en-US" sz="1100" dirty="0">
+                <a:solidFill>
+                  <a:srgbClr val="0070C0"/>
+                </a:solidFill>
+              </a:rPr>
+              <a:t>Here are confidence levels for Z (standard normal distribution):</a:t>
+            </a:r>
+          </a:p>
+        </p:txBody>
+      </p:sp>
+      <p:sp>
+        <p:nvSpPr>
+          <p:cNvPr id="10" name="TextBox 9">
+            <a:extLst>
+              <a:ext uri="{FF2B5EF4-FFF2-40B4-BE49-F238E27FC236}">
+                <a16:creationId xmlns:a16="http://schemas.microsoft.com/office/drawing/2014/main" id="{BEDE31FC-9B6C-CA4C-86AA-399D73F20ABC}"/>
+              </a:ext>
+            </a:extLst>
+          </p:cNvPr>
+          <p:cNvSpPr txBox="1"/>
+          <p:nvPr/>
+        </p:nvSpPr>
+        <p:spPr>
+          <a:xfrm>
+            <a:off x="6685723" y="3778096"/>
+            <a:ext cx="4167807" cy="307777"/>
+          </a:xfrm>
+          <a:prstGeom prst="rect">
+            <a:avLst/>
+          </a:prstGeom>
+          <a:noFill/>
+        </p:spPr>
+        <p:txBody>
+          <a:bodyPr wrap="square" rtlCol="0">
+            <a:spAutoFit/>
+          </a:bodyPr>
+          <a:lstStyle/>
+          <a:p>
+            <a:r>
+              <a:rPr lang="en-US" dirty="0">
+                <a:latin typeface="Calibri"/>
+                <a:cs typeface="Calibri"/>
+              </a:rPr>
+              <a:t>And hence the value of maximum error (E) is given by:</a:t>
+            </a:r>
+          </a:p>
+        </p:txBody>
+      </p:sp>
+      <p:pic>
+        <p:nvPicPr>
+          <p:cNvPr id="11" name="Picture 10">
+            <a:extLst>
+              <a:ext uri="{FF2B5EF4-FFF2-40B4-BE49-F238E27FC236}">
+                <a16:creationId xmlns:a16="http://schemas.microsoft.com/office/drawing/2014/main" id="{72637CC1-BEE4-154D-98AD-65986D051565}"/>
+              </a:ext>
+            </a:extLst>
+          </p:cNvPr>
+          <p:cNvPicPr>
+            <a:picLocks noChangeAspect="1"/>
+          </p:cNvPicPr>
+          <p:nvPr/>
+        </p:nvPicPr>
+        <p:blipFill>
+          <a:blip r:embed="rId6"/>
+          <a:stretch>
+            <a:fillRect/>
+          </a:stretch>
+        </p:blipFill>
+        <p:spPr>
+          <a:xfrm>
+            <a:off x="7798076" y="4074337"/>
+            <a:ext cx="1943100" cy="723900"/>
+          </a:xfrm>
+          <a:prstGeom prst="rect">
+            <a:avLst/>
+          </a:prstGeom>
+        </p:spPr>
+      </p:pic>
+      <p:sp>
+        <p:nvSpPr>
+          <p:cNvPr id="14" name="TextBox 13">
+            <a:extLst>
+              <a:ext uri="{FF2B5EF4-FFF2-40B4-BE49-F238E27FC236}">
+                <a16:creationId xmlns:a16="http://schemas.microsoft.com/office/drawing/2014/main" id="{638FBC29-A8F9-284A-A1BF-DA59A1CFE356}"/>
+              </a:ext>
+            </a:extLst>
+          </p:cNvPr>
+          <p:cNvSpPr txBox="1"/>
+          <p:nvPr/>
+        </p:nvSpPr>
+        <p:spPr>
+          <a:xfrm>
+            <a:off x="6685722" y="4749764"/>
+            <a:ext cx="430695" cy="307777"/>
+          </a:xfrm>
+          <a:prstGeom prst="rect">
+            <a:avLst/>
+          </a:prstGeom>
+          <a:noFill/>
+        </p:spPr>
+        <p:txBody>
+          <a:bodyPr wrap="square" rtlCol="0">
+            <a:spAutoFit/>
+          </a:bodyPr>
+          <a:lstStyle/>
+          <a:p>
+            <a:r>
+              <a:rPr lang="en-US" dirty="0">
+                <a:latin typeface="Calibri"/>
+                <a:cs typeface="Calibri"/>
+              </a:rPr>
+              <a:t>Or:</a:t>
+            </a:r>
+          </a:p>
+        </p:txBody>
+      </p:sp>
+      <p:pic>
+        <p:nvPicPr>
+          <p:cNvPr id="12" name="Picture 11">
+            <a:extLst>
+              <a:ext uri="{FF2B5EF4-FFF2-40B4-BE49-F238E27FC236}">
+                <a16:creationId xmlns:a16="http://schemas.microsoft.com/office/drawing/2014/main" id="{4BC789A4-98D4-F041-9CDE-34D490398ACE}"/>
+              </a:ext>
+            </a:extLst>
+          </p:cNvPr>
+          <p:cNvPicPr>
+            <a:picLocks noChangeAspect="1"/>
+          </p:cNvPicPr>
+          <p:nvPr/>
+        </p:nvPicPr>
+        <p:blipFill>
+          <a:blip r:embed="rId7"/>
+          <a:stretch>
+            <a:fillRect/>
+          </a:stretch>
+        </p:blipFill>
+        <p:spPr>
+          <a:xfrm>
+            <a:off x="7756936" y="4784985"/>
+            <a:ext cx="1155700" cy="723900"/>
+          </a:xfrm>
+          <a:prstGeom prst="rect">
+            <a:avLst/>
+          </a:prstGeom>
+        </p:spPr>
+      </p:pic>
+      <p:sp>
+        <p:nvSpPr>
+          <p:cNvPr id="16" name="TextBox 15">
+            <a:extLst>
+              <a:ext uri="{FF2B5EF4-FFF2-40B4-BE49-F238E27FC236}">
+                <a16:creationId xmlns:a16="http://schemas.microsoft.com/office/drawing/2014/main" id="{E141235E-B306-274B-AF92-68211AC9662B}"/>
+              </a:ext>
+            </a:extLst>
+          </p:cNvPr>
+          <p:cNvSpPr txBox="1"/>
+          <p:nvPr/>
+        </p:nvSpPr>
+        <p:spPr>
+          <a:xfrm>
+            <a:off x="6685722" y="5516224"/>
+            <a:ext cx="5082208" cy="738664"/>
+          </a:xfrm>
+          <a:prstGeom prst="rect">
+            <a:avLst/>
+          </a:prstGeom>
+          <a:noFill/>
+        </p:spPr>
+        <p:txBody>
+          <a:bodyPr wrap="square" rtlCol="0">
+            <a:spAutoFit/>
+          </a:bodyPr>
+          <a:lstStyle/>
+          <a:p>
+            <a:r>
+              <a:rPr lang="en-US" dirty="0">
+                <a:latin typeface="Calibri"/>
+                <a:cs typeface="Calibri"/>
+              </a:rPr>
+              <a:t>For example, if we want confidence 95% (Z=1.9599), then </a:t>
+            </a:r>
+          </a:p>
+          <a:p>
+            <a:pPr marL="285750" indent="-285750">
+              <a:buFont typeface="Arial" panose="020B0604020202020204" pitchFamily="34" charset="0"/>
+              <a:buChar char="•"/>
+            </a:pPr>
+            <a:r>
+              <a:rPr lang="en-US" dirty="0">
+                <a:latin typeface="Calibri"/>
+                <a:cs typeface="Calibri"/>
+              </a:rPr>
+              <a:t>for E=0.25 we need n = (1.9599)**2 / (4*0.25**2) = 16 flips  </a:t>
+            </a:r>
+          </a:p>
+          <a:p>
+            <a:pPr marL="285750" indent="-285750">
+              <a:buFont typeface="Arial" panose="020B0604020202020204" pitchFamily="34" charset="0"/>
+              <a:buChar char="•"/>
+            </a:pPr>
+            <a:r>
+              <a:rPr lang="en-US" dirty="0">
+                <a:latin typeface="Calibri"/>
+                <a:cs typeface="Calibri"/>
+              </a:rPr>
+              <a:t>for E=0.01, we need n = (1.9599)**2 /(4*0.01**2) = 9,603 flips</a:t>
+            </a:r>
+          </a:p>
+        </p:txBody>
+      </p:sp>
+      <p:pic>
+        <p:nvPicPr>
+          <p:cNvPr id="17" name="Picture 16">
+            <a:extLst>
+              <a:ext uri="{FF2B5EF4-FFF2-40B4-BE49-F238E27FC236}">
+                <a16:creationId xmlns:a16="http://schemas.microsoft.com/office/drawing/2014/main" id="{FDA8289B-60D2-814C-8237-AC0CE17777E4}"/>
+              </a:ext>
+            </a:extLst>
+          </p:cNvPr>
+          <p:cNvPicPr>
+            <a:picLocks noChangeAspect="1"/>
+          </p:cNvPicPr>
+          <p:nvPr/>
+        </p:nvPicPr>
+        <p:blipFill rotWithShape="1">
+          <a:blip r:embed="rId8" cstate="email">
+            <a:extLst>
+              <a:ext uri="{28A0092B-C50C-407E-A947-70E740481C1C}">
+                <a14:useLocalDpi xmlns:a14="http://schemas.microsoft.com/office/drawing/2010/main"/>
+              </a:ext>
+            </a:extLst>
+          </a:blip>
+          <a:srcRect l="1792" r="8013"/>
+          <a:stretch/>
+        </p:blipFill>
+        <p:spPr>
+          <a:xfrm>
+            <a:off x="3847264" y="4563788"/>
+            <a:ext cx="2437946" cy="1604169"/>
+          </a:xfrm>
+          <a:prstGeom prst="rect">
+            <a:avLst/>
+          </a:prstGeom>
+        </p:spPr>
+      </p:pic>
+    </p:spTree>
+  </p:cSld>
+  <p:clrMapOvr>
+    <a:masterClrMapping/>
+  </p:clrMapOvr>
+</p:sld>
+</file>
+
+<file path=ppt/slides/slide4.xml><?xml version="1.0" encoding="utf-8"?>
+<p:sld xmlns:a="http://schemas.openxmlformats.org/drawingml/2006/main" xmlns:r="http://schemas.openxmlformats.org/officeDocument/2006/relationships" xmlns:p="http://schemas.openxmlformats.org/presentationml/2006/main">
+  <p:cSld>
+    <p:spTree>
+      <p:nvGrpSpPr>
+        <p:cNvPr id="1" name="Shape 113"/>
+        <p:cNvGrpSpPr/>
+        <p:nvPr/>
+      </p:nvGrpSpPr>
+      <p:grpSpPr>
+        <a:xfrm>
+          <a:off x="0" y="0"/>
+          <a:ext cx="0" cy="0"/>
+          <a:chOff x="0" y="0"/>
+          <a:chExt cx="0" cy="0"/>
+        </a:xfrm>
+      </p:grpSpPr>
+      <p:sp>
+        <p:nvSpPr>
           <p:cNvPr id="114" name="Google Shape;114;p16"/>
           <p:cNvSpPr txBox="1"/>
           <p:nvPr/>
         </p:nvSpPr>
         <p:spPr>
           <a:xfrm>
-            <a:off x="476739" y="3130787"/>
+            <a:off x="383974" y="715279"/>
             <a:ext cx="4877100" cy="3147000"/>
           </a:xfrm>
           <a:prstGeom prst="rect">
@@ -16975,7 +18460,7 @@
         </p:nvSpPr>
         <p:spPr>
           <a:xfrm>
-            <a:off x="6067250" y="238200"/>
+            <a:off x="6067250" y="715279"/>
             <a:ext cx="5707800" cy="5944200"/>
           </a:xfrm>
           <a:prstGeom prst="rect">
@@ -17395,10 +18880,10 @@
       </p:sp>
       <p:sp>
         <p:nvSpPr>
-          <p:cNvPr id="4" name="Google Shape;114;p16">
+          <p:cNvPr id="2" name="TextBox 1">
             <a:extLst>
               <a:ext uri="{FF2B5EF4-FFF2-40B4-BE49-F238E27FC236}">
-                <a16:creationId xmlns:a16="http://schemas.microsoft.com/office/drawing/2014/main" id="{2852508B-C5FD-2C4A-AFD6-7CEC0F45E3A7}"/>
+                <a16:creationId xmlns:a16="http://schemas.microsoft.com/office/drawing/2014/main" id="{7D2AE4FC-9024-9547-829E-724CC7A63A22}"/>
               </a:ext>
             </a:extLst>
           </p:cNvPr>
@@ -17407,147 +18892,33 @@
         </p:nvSpPr>
         <p:spPr>
           <a:xfrm>
-            <a:off x="364096" y="238200"/>
-            <a:ext cx="4877100" cy="2306217"/>
+            <a:off x="92765" y="106017"/>
+            <a:ext cx="2637183" cy="400110"/>
           </a:xfrm>
           <a:prstGeom prst="rect">
             <a:avLst/>
           </a:prstGeom>
           <a:noFill/>
-          <a:ln>
-            <a:noFill/>
-          </a:ln>
         </p:spPr>
         <p:txBody>
-          <a:bodyPr spcFirstLastPara="1" wrap="square" lIns="91425" tIns="91425" rIns="91425" bIns="91425" anchor="t" anchorCtr="0">
-            <a:noAutofit/>
+          <a:bodyPr wrap="square" rtlCol="0">
+            <a:spAutoFit/>
           </a:bodyPr>
           <a:lstStyle/>
           <a:p>
-            <a:pPr marL="0" lvl="0" indent="0" algn="l" rtl="0">
-              <a:spcBef>
-                <a:spcPts val="0"/>
-              </a:spcBef>
-              <a:spcAft>
-                <a:spcPts val="0"/>
-              </a:spcAft>
-              <a:buNone/>
-            </a:pPr>
-            <a:r>
-              <a:rPr lang="en-US" dirty="0">
-                <a:latin typeface="Calibri"/>
-                <a:ea typeface="Calibri"/>
-                <a:cs typeface="Calibri"/>
-                <a:sym typeface="Calibri"/>
-              </a:rPr>
-              <a:t>Problem0:</a:t>
-            </a:r>
-            <a:endParaRPr dirty="0">
-              <a:latin typeface="Calibri"/>
-              <a:ea typeface="Calibri"/>
-              <a:cs typeface="Calibri"/>
-              <a:sym typeface="Calibri"/>
-            </a:endParaRPr>
-          </a:p>
-          <a:p>
-            <a:pPr marL="0" lvl="0" indent="0" algn="l" rtl="0">
-              <a:spcBef>
-                <a:spcPts val="0"/>
-              </a:spcBef>
-              <a:spcAft>
-                <a:spcPts val="0"/>
-              </a:spcAft>
-              <a:buNone/>
-            </a:pPr>
-            <a:endParaRPr dirty="0">
-              <a:latin typeface="Calibri"/>
-              <a:ea typeface="Calibri"/>
-              <a:cs typeface="Calibri"/>
-              <a:sym typeface="Calibri"/>
-            </a:endParaRPr>
-          </a:p>
-          <a:p>
-            <a:pPr marL="0" lvl="0" indent="0" algn="l" rtl="0">
-              <a:spcBef>
-                <a:spcPts val="0"/>
-              </a:spcBef>
-              <a:spcAft>
-                <a:spcPts val="0"/>
-              </a:spcAft>
-              <a:buNone/>
-            </a:pPr>
-            <a:r>
-              <a:rPr lang="en-US" dirty="0">
-                <a:latin typeface="Calibri"/>
-                <a:ea typeface="Calibri"/>
-                <a:cs typeface="Calibri"/>
-                <a:sym typeface="Calibri"/>
-              </a:rPr>
-              <a:t>We tossed a coin 10 times and got 8 heads. Compute p-value.</a:t>
-            </a:r>
-          </a:p>
-          <a:p>
-            <a:pPr lvl="0"/>
-            <a:r>
-              <a:rPr lang="en-US" dirty="0">
-                <a:latin typeface="Calibri"/>
-                <a:ea typeface="Calibri"/>
-                <a:cs typeface="Calibri"/>
-                <a:sym typeface="Calibri"/>
-              </a:rPr>
-              <a:t>To compute the p-value we just need compute the probability of 8 or more heads in 10 tosses (assuming the coin is fair).</a:t>
-            </a:r>
-            <a:br>
-              <a:rPr lang="en-US" dirty="0">
-                <a:latin typeface="Calibri"/>
-                <a:ea typeface="Calibri"/>
-                <a:cs typeface="Calibri"/>
-                <a:sym typeface="Calibri"/>
-              </a:rPr>
-            </a:br>
-            <a:endParaRPr lang="en-US" dirty="0">
-              <a:latin typeface="Calibri"/>
-              <a:ea typeface="Calibri"/>
-              <a:cs typeface="Calibri"/>
-              <a:sym typeface="Calibri"/>
-            </a:endParaRPr>
-          </a:p>
-          <a:p>
-            <a:pPr lvl="0"/>
-            <a:r>
-              <a:rPr lang="en-US" dirty="0">
-                <a:latin typeface="Calibri"/>
-                <a:ea typeface="Calibri"/>
-                <a:cs typeface="Calibri"/>
-                <a:sym typeface="Calibri"/>
-              </a:rPr>
-              <a:t>Note that the number of heads follows a binomial distribution with n=10 and p=0.5.</a:t>
-            </a:r>
-          </a:p>
-          <a:p>
-            <a:pPr lvl="0"/>
-            <a:endParaRPr lang="en-US" dirty="0">
-              <a:latin typeface="Calibri"/>
-              <a:ea typeface="Calibri"/>
-              <a:cs typeface="Calibri"/>
-              <a:sym typeface="Calibri"/>
-            </a:endParaRPr>
-          </a:p>
-          <a:p>
-            <a:pPr lvl="0"/>
-            <a:r>
-              <a:rPr lang="en-US" dirty="0">
-                <a:latin typeface="Calibri"/>
-                <a:ea typeface="Calibri"/>
-                <a:cs typeface="Calibri"/>
-                <a:sym typeface="Calibri"/>
-              </a:rPr>
-              <a:t>So the p-value = P[8] + P[9] + P[10] = .044 + .01 + .001 = 0.055.</a:t>
+            <a:r>
+              <a:rPr lang="en-US" sz="2000" b="1" dirty="0"/>
+              <a:t>Hypothesis Testing</a:t>
             </a:r>
           </a:p>
         </p:txBody>
       </p:sp>
     </p:spTree>
+    <p:extLst>
+      <p:ext uri="{BB962C8B-B14F-4D97-AF65-F5344CB8AC3E}">
+        <p14:creationId xmlns:p14="http://schemas.microsoft.com/office/powerpoint/2010/main" val="3916857598"/>
+      </p:ext>
+    </p:extLst>
   </p:cSld>
   <p:clrMapOvr>
     <a:masterClrMapping/>
@@ -17555,7 +18926,7 @@
 </p:sld>
 </file>
 
-<file path=ppt/slides/slide4.xml><?xml version="1.0" encoding="utf-8"?>
+<file path=ppt/slides/slide5.xml><?xml version="1.0" encoding="utf-8"?>
 <p:sld xmlns:a="http://schemas.openxmlformats.org/drawingml/2006/main" xmlns:r="http://schemas.openxmlformats.org/officeDocument/2006/relationships" xmlns:p="http://schemas.openxmlformats.org/presentationml/2006/main">
   <p:cSld>
     <p:spTree>
@@ -17821,7 +19192,7 @@
 </p:sld>
 </file>
 
-<file path=ppt/slides/slide5.xml><?xml version="1.0" encoding="utf-8"?>
+<file path=ppt/slides/slide6.xml><?xml version="1.0" encoding="utf-8"?>
 <p:sld xmlns:a="http://schemas.openxmlformats.org/drawingml/2006/main" xmlns:r="http://schemas.openxmlformats.org/officeDocument/2006/relationships" xmlns:p="http://schemas.openxmlformats.org/presentationml/2006/main">
   <p:cSld>
     <p:spTree>
@@ -19231,7 +20602,7 @@
 </p:sld>
 </file>
 
-<file path=ppt/slides/slide6.xml><?xml version="1.0" encoding="utf-8"?>
+<file path=ppt/slides/slide7.xml><?xml version="1.0" encoding="utf-8"?>
 <p:sld xmlns:a="http://schemas.openxmlformats.org/drawingml/2006/main" xmlns:r="http://schemas.openxmlformats.org/officeDocument/2006/relationships" xmlns:p="http://schemas.openxmlformats.org/presentationml/2006/main">
   <p:cSld>
     <p:spTree>

</xml_diff>